<commit_message>
flee from danger fixed
</commit_message>
<xml_diff>
--- a/GPP_ZombieAI_LastNameFirstName_2DAEXX.pptx
+++ b/GPP_ZombieAI_LastNameFirstName_2DAEXX.pptx
@@ -405,7 +405,7 @@
           <a:p>
             <a:fld id="{82085877-2B37-48E7-8B6D-4D4ED486130A}" type="datetimeFigureOut">
               <a:rPr lang="en-BE" smtClean="0"/>
-              <a:t>11/28/2023</a:t>
+              <a:t>06/07/2026</a:t>
             </a:fld>
             <a:endParaRPr lang="en-BE"/>
           </a:p>
@@ -605,7 +605,7 @@
           <a:p>
             <a:fld id="{82085877-2B37-48E7-8B6D-4D4ED486130A}" type="datetimeFigureOut">
               <a:rPr lang="en-BE" smtClean="0"/>
-              <a:t>11/28/2023</a:t>
+              <a:t>06/07/2026</a:t>
             </a:fld>
             <a:endParaRPr lang="en-BE"/>
           </a:p>
@@ -815,7 +815,7 @@
           <a:p>
             <a:fld id="{82085877-2B37-48E7-8B6D-4D4ED486130A}" type="datetimeFigureOut">
               <a:rPr lang="en-BE" smtClean="0"/>
-              <a:t>11/28/2023</a:t>
+              <a:t>06/07/2026</a:t>
             </a:fld>
             <a:endParaRPr lang="en-BE"/>
           </a:p>
@@ -1015,7 +1015,7 @@
           <a:p>
             <a:fld id="{82085877-2B37-48E7-8B6D-4D4ED486130A}" type="datetimeFigureOut">
               <a:rPr lang="en-BE" smtClean="0"/>
-              <a:t>11/28/2023</a:t>
+              <a:t>06/07/2026</a:t>
             </a:fld>
             <a:endParaRPr lang="en-BE"/>
           </a:p>
@@ -1291,7 +1291,7 @@
           <a:p>
             <a:fld id="{82085877-2B37-48E7-8B6D-4D4ED486130A}" type="datetimeFigureOut">
               <a:rPr lang="en-BE" smtClean="0"/>
-              <a:t>11/28/2023</a:t>
+              <a:t>06/07/2026</a:t>
             </a:fld>
             <a:endParaRPr lang="en-BE"/>
           </a:p>
@@ -1559,7 +1559,7 @@
           <a:p>
             <a:fld id="{82085877-2B37-48E7-8B6D-4D4ED486130A}" type="datetimeFigureOut">
               <a:rPr lang="en-BE" smtClean="0"/>
-              <a:t>11/28/2023</a:t>
+              <a:t>06/07/2026</a:t>
             </a:fld>
             <a:endParaRPr lang="en-BE"/>
           </a:p>
@@ -1974,7 +1974,7 @@
           <a:p>
             <a:fld id="{82085877-2B37-48E7-8B6D-4D4ED486130A}" type="datetimeFigureOut">
               <a:rPr lang="en-BE" smtClean="0"/>
-              <a:t>11/28/2023</a:t>
+              <a:t>06/07/2026</a:t>
             </a:fld>
             <a:endParaRPr lang="en-BE"/>
           </a:p>
@@ -2116,7 +2116,7 @@
           <a:p>
             <a:fld id="{82085877-2B37-48E7-8B6D-4D4ED486130A}" type="datetimeFigureOut">
               <a:rPr lang="en-BE" smtClean="0"/>
-              <a:t>11/28/2023</a:t>
+              <a:t>06/07/2026</a:t>
             </a:fld>
             <a:endParaRPr lang="en-BE"/>
           </a:p>
@@ -2229,7 +2229,7 @@
           <a:p>
             <a:fld id="{82085877-2B37-48E7-8B6D-4D4ED486130A}" type="datetimeFigureOut">
               <a:rPr lang="en-BE" smtClean="0"/>
-              <a:t>11/28/2023</a:t>
+              <a:t>06/07/2026</a:t>
             </a:fld>
             <a:endParaRPr lang="en-BE"/>
           </a:p>
@@ -2542,7 +2542,7 @@
           <a:p>
             <a:fld id="{82085877-2B37-48E7-8B6D-4D4ED486130A}" type="datetimeFigureOut">
               <a:rPr lang="en-BE" smtClean="0"/>
-              <a:t>11/28/2023</a:t>
+              <a:t>06/07/2026</a:t>
             </a:fld>
             <a:endParaRPr lang="en-BE"/>
           </a:p>
@@ -2831,7 +2831,7 @@
           <a:p>
             <a:fld id="{82085877-2B37-48E7-8B6D-4D4ED486130A}" type="datetimeFigureOut">
               <a:rPr lang="en-BE" smtClean="0"/>
-              <a:t>11/28/2023</a:t>
+              <a:t>06/07/2026</a:t>
             </a:fld>
             <a:endParaRPr lang="en-BE"/>
           </a:p>
@@ -3074,7 +3074,7 @@
           <a:p>
             <a:fld id="{82085877-2B37-48E7-8B6D-4D4ED486130A}" type="datetimeFigureOut">
               <a:rPr lang="en-BE" smtClean="0"/>
-              <a:t>11/28/2023</a:t>
+              <a:t>06/07/2026</a:t>
             </a:fld>
             <a:endParaRPr lang="en-BE"/>
           </a:p>
@@ -4534,6 +4534,28 @@
 </a:theme>
 </file>
 
+<file path=ppt/webextensions/taskpanes.xml><?xml version="1.0" encoding="utf-8"?>
+<wetp:taskpanes xmlns:wetp="http://schemas.microsoft.com/office/webextensions/taskpanes/2010/11">
+  <wetp:taskpane dockstate="right" visibility="0" width="438" row="0">
+    <wetp:webextensionref xmlns:r="http://schemas.openxmlformats.org/officeDocument/2006/relationships" r:id="rId1"/>
+  </wetp:taskpane>
+</wetp:taskpanes>
+</file>
+
+<file path=ppt/webextensions/webextension1.xml><?xml version="1.0" encoding="utf-8"?>
+<we:webextension xmlns:we="http://schemas.microsoft.com/office/webextensions/webextension/2010/11" id="{051FA549-68CC-49A1-82DE-27CD7D3E37DC}">
+  <we:reference id="wa200010001" version="1.0.0.1" store="tr-TR" storeType="OMEX"/>
+  <we:alternateReferences>
+    <we:reference id="wa200010001" version="1.0.0.1" store="wa200010001" storeType="OMEX"/>
+  </we:alternateReferences>
+  <we:properties>
+    <we:property name="claude.fileId" value="&quot;ef4b62f7-9b1a-4aa3-b303-55b9f6f283a1&quot;"/>
+  </we:properties>
+  <we:bindings/>
+  <we:snapshot xmlns:r="http://schemas.openxmlformats.org/officeDocument/2006/relationships"/>
+</we:webextension>
+</file>
+
 <file path=customXml/item1.xml><?xml version="1.0" encoding="utf-8"?>
 <?mso-contentType ?>
 <FormTemplates xmlns="http://schemas.microsoft.com/sharepoint/v3/contenttype/forms">
@@ -4544,6 +4566,21 @@
 </file>
 
 <file path=customXml/item2.xml><?xml version="1.0" encoding="utf-8"?>
+<p:properties xmlns:p="http://schemas.microsoft.com/office/2006/metadata/properties" xmlns:xsi="http://www.w3.org/2001/XMLSchema-instance" xmlns:pc="http://schemas.microsoft.com/office/infopath/2007/PartnerControls">
+  <documentManagement>
+    <IconOverlay xmlns="http://schemas.microsoft.com/sharepoint/v4" xsi:nil="true"/>
+    <TaxCatchAll xmlns="128482ec-0431-40d5-ab26-89ea2a4f3ccd" xsi:nil="true"/>
+    <m99485b88215436a82099f8287cba0b0 xmlns="128482ec-0431-40d5-ab26-89ea2a4f3ccd">
+      <Terms xmlns="http://schemas.microsoft.com/office/infopath/2007/PartnerControls"/>
+    </m99485b88215436a82099f8287cba0b0>
+    <lcf76f155ced4ddcb4097134ff3c332f xmlns="60eb0cf4-ae2a-4762-800a-cb593b869ecb">
+      <Terms xmlns="http://schemas.microsoft.com/office/infopath/2007/PartnerControls"/>
+    </lcf76f155ced4ddcb4097134ff3c332f>
+  </documentManagement>
+</p:properties>
+</file>
+
+<file path=customXml/item3.xml><?xml version="1.0" encoding="utf-8"?>
 <ct:contentTypeSchema xmlns:ct="http://schemas.microsoft.com/office/2006/metadata/contentType" xmlns:ma="http://schemas.microsoft.com/office/2006/metadata/properties/metaAttributes" ct:_="" ma:_="" ma:contentTypeName="Document" ma:contentTypeID="0x010100723942CCEB3A674D8F1F6472CCEFB38E" ma:contentTypeVersion="11" ma:contentTypeDescription="Create a new document." ma:contentTypeScope="" ma:versionID="e4de40d148e029d40e3aaddc8bf68a5e">
   <xsd:schema xmlns:xsd="http://www.w3.org/2001/XMLSchema" xmlns:xs="http://www.w3.org/2001/XMLSchema" xmlns:p="http://schemas.microsoft.com/office/2006/metadata/properties" xmlns:ns2="128482ec-0431-40d5-ab26-89ea2a4f3ccd" xmlns:ns3="60eb0cf4-ae2a-4762-800a-cb593b869ecb" xmlns:ns4="http://schemas.microsoft.com/sharepoint/v4" xmlns:ns5="a2e691a9-fcfc-4d85-a390-1894fe98bd9e" targetNamespace="http://schemas.microsoft.com/office/2006/metadata/properties" ma:root="true" ma:fieldsID="fce8e8bd091658f3fe51b22d57dec109" ns2:_="" ns3:_="" ns4:_="" ns5:_="">
     <xsd:import namespace="128482ec-0431-40d5-ab26-89ea2a4f3ccd"/>
@@ -4816,21 +4853,6 @@
 </ct:contentTypeSchema>
 </file>
 
-<file path=customXml/item3.xml><?xml version="1.0" encoding="utf-8"?>
-<p:properties xmlns:p="http://schemas.microsoft.com/office/2006/metadata/properties" xmlns:xsi="http://www.w3.org/2001/XMLSchema-instance" xmlns:pc="http://schemas.microsoft.com/office/infopath/2007/PartnerControls">
-  <documentManagement>
-    <IconOverlay xmlns="http://schemas.microsoft.com/sharepoint/v4" xsi:nil="true"/>
-    <TaxCatchAll xmlns="128482ec-0431-40d5-ab26-89ea2a4f3ccd" xsi:nil="true"/>
-    <m99485b88215436a82099f8287cba0b0 xmlns="128482ec-0431-40d5-ab26-89ea2a4f3ccd">
-      <Terms xmlns="http://schemas.microsoft.com/office/infopath/2007/PartnerControls"/>
-    </m99485b88215436a82099f8287cba0b0>
-    <lcf76f155ced4ddcb4097134ff3c332f xmlns="60eb0cf4-ae2a-4762-800a-cb593b869ecb">
-      <Terms xmlns="http://schemas.microsoft.com/office/infopath/2007/PartnerControls"/>
-    </lcf76f155ced4ddcb4097134ff3c332f>
-  </documentManagement>
-</p:properties>
-</file>
-
 <file path=customXml/itemProps1.xml><?xml version="1.0" encoding="utf-8"?>
 <ds:datastoreItem xmlns:ds="http://schemas.openxmlformats.org/officeDocument/2006/customXml" ds:itemID="{AF8EC6D1-CB19-4400-AD0A-0C75CD884AEA}">
   <ds:schemaRefs>
@@ -4840,6 +4862,18 @@
 </file>
 
 <file path=customXml/itemProps2.xml><?xml version="1.0" encoding="utf-8"?>
+<ds:datastoreItem xmlns:ds="http://schemas.openxmlformats.org/officeDocument/2006/customXml" ds:itemID="{B743389A-7EE0-4951-8919-E91DD69E3687}">
+  <ds:schemaRefs>
+    <ds:schemaRef ds:uri="128482ec-0431-40d5-ab26-89ea2a4f3ccd"/>
+    <ds:schemaRef ds:uri="http://schemas.microsoft.com/office/2006/metadata/properties"/>
+    <ds:schemaRef ds:uri="http://schemas.microsoft.com/office/infopath/2007/PartnerControls"/>
+    <ds:schemaRef ds:uri="http://schemas.microsoft.com/sharepoint/v4"/>
+    <ds:schemaRef ds:uri="60eb0cf4-ae2a-4762-800a-cb593b869ecb"/>
+  </ds:schemaRefs>
+</ds:datastoreItem>
+</file>
+
+<file path=customXml/itemProps3.xml><?xml version="1.0" encoding="utf-8"?>
 <ds:datastoreItem xmlns:ds="http://schemas.openxmlformats.org/officeDocument/2006/customXml" ds:itemID="{D7B8C5DE-3345-4025-A942-C5AA68E55545}">
   <ds:schemaRefs>
     <ds:schemaRef ds:uri="http://schemas.microsoft.com/office/2006/metadata/contentType"/>
@@ -4858,16 +4892,4 @@
     <ds:schemaRef ds:uri="http://schemas.microsoft.com/internal/obd"/>
   </ds:schemaRefs>
 </ds:datastoreItem>
-</file>
-
-<file path=customXml/itemProps3.xml><?xml version="1.0" encoding="utf-8"?>
-<ds:datastoreItem xmlns:ds="http://schemas.openxmlformats.org/officeDocument/2006/customXml" ds:itemID="{B743389A-7EE0-4951-8919-E91DD69E3687}">
-  <ds:schemaRefs>
-    <ds:schemaRef ds:uri="128482ec-0431-40d5-ab26-89ea2a4f3ccd"/>
-    <ds:schemaRef ds:uri="http://schemas.microsoft.com/office/2006/metadata/properties"/>
-    <ds:schemaRef ds:uri="http://schemas.microsoft.com/office/infopath/2007/PartnerControls"/>
-    <ds:schemaRef ds:uri="http://schemas.microsoft.com/sharepoint/v4"/>
-    <ds:schemaRef ds:uri="60eb0cf4-ae2a-4762-800a-cb593b869ecb"/>
-  </ds:schemaRefs>
-</ds:datastoreItem>
 </file>
</xml_diff>